<commit_message>
docs(capstone): drop the references sections from reports and deck
Remove the annotated references from report.md, the 'Key methods and their
sources' section from qc-report.md, the References backup slide from
slides.md, and related mentions in demo-script.md; regenerate PDF/PPTX.
</commit_message>
<xml_diff>
--- a/capstone/docs/qc-report.pptx
+++ b/capstone/docs/qc-report.pptx
@@ -21,7 +21,6 @@
     <p:sldId id="269" r:id="rId15"/>
     <p:sldId id="270" r:id="rId16"/>
     <p:sldId id="271" r:id="rId17"/>
-    <p:sldId id="272" r:id="rId18"/>
   </p:sldIdLst>
   <p:sldSz cx="9144000" cy="5143500" type="screen16x9"/>
   <p:notesSz cx="6858000" cy="9144000"/>
@@ -5076,140 +5075,6 @@
             <a:r>
               <a:rPr/>
               <a:t>, which the figure script writes from the pipeline artifacts.</a:t>
-            </a:r>
-          </a:p>
-        </p:txBody>
-      </p:sp>
-    </p:spTree>
-  </p:cSld>
-</p:sld>
-</file>
-
-<file path=ppt/slides/slide17.xml><?xml version="1.0" encoding="utf-8"?>
-<p:sld xmlns:a="http://schemas.openxmlformats.org/drawingml/2006/main" xmlns:r="http://schemas.openxmlformats.org/officeDocument/2006/relationships" xmlns:p="http://schemas.openxmlformats.org/presentationml/2006/main">
-  <p:cSld>
-    <p:spTree>
-      <p:nvGrpSpPr>
-        <p:cNvPr id="1" name=""/>
-        <p:cNvGrpSpPr/>
-        <p:nvPr/>
-      </p:nvGrpSpPr>
-      <p:grpSpPr>
-        <a:xfrm>
-          <a:off x="0" y="0"/>
-          <a:ext cx="0" cy="0"/>
-          <a:chOff x="0" y="0"/>
-          <a:chExt cx="0" cy="0"/>
-        </a:xfrm>
-      </p:grpSpPr>
-      <p:sp>
-        <p:nvSpPr>
-          <p:cNvPr id="2" name="Title 1"/>
-          <p:cNvSpPr>
-            <a:spLocks noGrp="1"/>
-          </p:cNvSpPr>
-          <p:nvPr>
-            <p:ph type="title"/>
-          </p:nvPr>
-        </p:nvSpPr>
-        <p:spPr/>
-        <p:txBody>
-          <a:bodyPr/>
-          <a:lstStyle/>
-          <a:p>
-            <a:pPr lvl="0" indent="0" marL="0">
-              <a:buNone/>
-            </a:pPr>
-            <a:r>
-              <a:rPr/>
-              <a:t>9. Key methods and their sources (in one line each)</a:t>
-            </a:r>
-          </a:p>
-        </p:txBody>
-      </p:sp>
-      <p:sp>
-        <p:nvSpPr>
-          <p:cNvPr id="3" name="Content Placeholder 2"/>
-          <p:cNvSpPr>
-            <a:spLocks noGrp="1"/>
-          </p:cNvSpPr>
-          <p:nvPr>
-            <p:ph idx="1"/>
-          </p:nvPr>
-        </p:nvSpPr>
-        <p:spPr/>
-        <p:txBody>
-          <a:bodyPr/>
-          <a:lstStyle/>
-          <a:p>
-            <a:pPr lvl="0" indent="-342900" marL="342900">
-              <a:buAutoNum type="arabicPeriod"/>
-            </a:pPr>
-            <a:r>
-              <a:rPr b="1"/>
-              <a:t>Sentence-BERT</a:t>
-            </a:r>
-            <a:r>
-              <a:rPr/>
-              <a:t> (Reimers &amp; Gurevych, 2019) - how to train transformer networks to produce high-quality sentence embeddings; the model family behind our 384-D vectors.</a:t>
-            </a:r>
-          </a:p>
-          <a:p>
-            <a:pPr lvl="0" indent="-342900" marL="342900">
-              <a:buAutoNum type="arabicPeriod"/>
-            </a:pPr>
-            <a:r>
-              <a:rPr b="1"/>
-              <a:t>UMAP</a:t>
-            </a:r>
-            <a:r>
-              <a:rPr/>
-              <a:t> (McInnes et al., 2018) - the dimensionality-reduction method used for the 2D projection.</a:t>
-            </a:r>
-          </a:p>
-          <a:p>
-            <a:pPr lvl="0" indent="-342900" marL="342900">
-              <a:buAutoNum type="arabicPeriod"/>
-            </a:pPr>
-            <a:r>
-              <a:rPr b="1"/>
-              <a:t>HDBSCAN</a:t>
-            </a:r>
-            <a:r>
-              <a:rPr/>
-              <a:t> (Campello et al., 2013) - the density-based clustering method used to group the corpus and mark noise.</a:t>
-            </a:r>
-          </a:p>
-          <a:p>
-            <a:pPr lvl="0" indent="-342900" marL="342900">
-              <a:buAutoNum type="arabicPeriod"/>
-            </a:pPr>
-            <a:r>
-              <a:rPr b="1"/>
-              <a:t>Isolation Forest</a:t>
-            </a:r>
-            <a:r>
-              <a:rPr/>
-              <a:t> (Liu, Ting &amp; Zhou, 2008) - the anomaly-detection method used to score unusual verbetes.</a:t>
-            </a:r>
-          </a:p>
-          <a:p>
-            <a:pPr lvl="0" indent="0" marL="0">
-              <a:buNone/>
-            </a:pPr>
-            <a:r>
-              <a:rPr/>
-              <a:t>You do not need to read these papers to follow this report; each is summarised above. Full citations appear in the technical report (</a:t>
-            </a:r>
-            <a:r>
-              <a:rPr>
-                <a:latin typeface="Courier"/>
-              </a:rPr>
-              <a:t>report.md</a:t>
-            </a:r>
-            <a:r>
-              <a:rPr/>
-              <a:t>).</a:t>
             </a:r>
           </a:p>
         </p:txBody>

</xml_diff>

<commit_message>
fix(capstone): robust CLI output for anomalies and cluster terms
The anomalies command crashed with KeyError: 'codigo' because
get_anomalies did not return that field. Include it and read it
defensively in the CLI.

Cluster top terms were raw tokens (stopwords, punctuation, dates).
Add a shared lib.text.top_terms helper that keeps only meaningful
alphabetic words, and use it from the CLI, the dashboard and the
report script so all three agree. The clusters command now reads the
body text from metadata, matching the reports instead of the
tema+text Chroma document.
</commit_message>
<xml_diff>
--- a/capstone/docs/qc-report.pptx
+++ b/capstone/docs/qc-report.pptx
@@ -4660,7 +4660,7 @@
                       </a:pPr>
                       <a:r>
                         <a:rPr/>
-                        <a:t>art., res., para, decorrência, súmula</a:t>
+                        <a:t>trabalho, súmula, decorrência, cancelada, empregado</a:t>
                       </a:r>
                     </a:p>
                   </a:txBody>
@@ -4707,7 +4707,7 @@
                       </a:pPr>
                       <a:r>
                         <a:rPr/>
-                        <a:t>concede, homologação, res., sessão</a:t>
+                        <a:t>concede, homologação, sessão, empregado</a:t>
                       </a:r>
                     </a:p>
                   </a:txBody>

</xml_diff>